<commit_message>
fix en pptx & readme ref
</commit_message>
<xml_diff>
--- a/docs_Illustration about UMI Data Frame.pptx
+++ b/docs_Illustration about UMI Data Frame.pptx
@@ -5,8 +5,8 @@
     <p:sldMasterId id="2147483648" r:id="rId1"/>
   </p:sldMasterIdLst>
   <p:sldIdLst>
-    <p:sldId id="257" r:id="rId2"/>
-    <p:sldId id="258" r:id="rId3"/>
+    <p:sldId id="257" r:id="rId3"/>
+    <p:sldId id="258" r:id="rId4"/>
   </p:sldIdLst>
   <p:sldSz cx="12192000" cy="6858000"/>
   <p:notesSz cx="6858000" cy="9144000"/>
@@ -169,6 +169,7 @@
               <a:rPr lang="zh-CN" altLang="en-US"/>
               <a:t>单击此处编辑母版标题样式</a:t>
             </a:r>
+            <a:endParaRPr lang="zh-CN" altLang="en-US"/>
           </a:p>
         </p:txBody>
       </p:sp>
@@ -233,6 +234,7 @@
               <a:rPr lang="zh-CN" altLang="en-US"/>
               <a:t>单击此处编辑母版副标题样式</a:t>
             </a:r>
+            <a:endParaRPr lang="zh-CN" altLang="en-US"/>
           </a:p>
         </p:txBody>
       </p:sp>
@@ -253,7 +255,6 @@
           <a:p>
             <a:fld id="{D997B5FA-0921-464F-AAE1-844C04324D75}" type="datetimeFigureOut">
               <a:rPr lang="zh-CN" altLang="en-US" smtClean="0"/>
-              <a:t>2026/7/8</a:t>
             </a:fld>
             <a:endParaRPr lang="zh-CN" altLang="en-US"/>
           </a:p>
@@ -295,7 +296,6 @@
           <a:p>
             <a:fld id="{565CE74E-AB26-4998-AD42-012C4C1AD076}" type="slidenum">
               <a:rPr lang="zh-CN" altLang="en-US" smtClean="0"/>
-              <a:t>‹#›</a:t>
             </a:fld>
             <a:endParaRPr lang="zh-CN" altLang="en-US"/>
           </a:p>
@@ -345,6 +345,7 @@
               <a:rPr lang="zh-CN" altLang="en-US"/>
               <a:t>单击此处编辑母版标题样式</a:t>
             </a:r>
+            <a:endParaRPr lang="zh-CN" altLang="en-US"/>
           </a:p>
         </p:txBody>
       </p:sp>
@@ -368,6 +369,7 @@
               <a:rPr lang="zh-CN" altLang="en-US"/>
               <a:t>单击此处编辑母版文本样式</a:t>
             </a:r>
+            <a:endParaRPr lang="zh-CN" altLang="en-US"/>
           </a:p>
           <a:p>
             <a:pPr lvl="1"/>
@@ -375,6 +377,7 @@
               <a:rPr lang="zh-CN" altLang="en-US"/>
               <a:t>第二级</a:t>
             </a:r>
+            <a:endParaRPr lang="zh-CN" altLang="en-US"/>
           </a:p>
           <a:p>
             <a:pPr lvl="2"/>
@@ -382,6 +385,7 @@
               <a:rPr lang="zh-CN" altLang="en-US"/>
               <a:t>第三级</a:t>
             </a:r>
+            <a:endParaRPr lang="zh-CN" altLang="en-US"/>
           </a:p>
           <a:p>
             <a:pPr lvl="3"/>
@@ -389,6 +393,7 @@
               <a:rPr lang="zh-CN" altLang="en-US"/>
               <a:t>第四级</a:t>
             </a:r>
+            <a:endParaRPr lang="zh-CN" altLang="en-US"/>
           </a:p>
           <a:p>
             <a:pPr lvl="4"/>
@@ -396,6 +401,7 @@
               <a:rPr lang="zh-CN" altLang="en-US"/>
               <a:t>第五级</a:t>
             </a:r>
+            <a:endParaRPr lang="zh-CN" altLang="en-US"/>
           </a:p>
         </p:txBody>
       </p:sp>
@@ -416,7 +422,6 @@
           <a:p>
             <a:fld id="{D997B5FA-0921-464F-AAE1-844C04324D75}" type="datetimeFigureOut">
               <a:rPr lang="zh-CN" altLang="en-US" smtClean="0"/>
-              <a:t>2026/7/8</a:t>
             </a:fld>
             <a:endParaRPr lang="zh-CN" altLang="en-US"/>
           </a:p>
@@ -458,7 +463,6 @@
           <a:p>
             <a:fld id="{565CE74E-AB26-4998-AD42-012C4C1AD076}" type="slidenum">
               <a:rPr lang="zh-CN" altLang="en-US" smtClean="0"/>
-              <a:t>‹#›</a:t>
             </a:fld>
             <a:endParaRPr lang="zh-CN" altLang="en-US"/>
           </a:p>
@@ -513,6 +517,7 @@
               <a:rPr lang="zh-CN" altLang="en-US"/>
               <a:t>单击此处编辑母版标题样式</a:t>
             </a:r>
+            <a:endParaRPr lang="zh-CN" altLang="en-US"/>
           </a:p>
         </p:txBody>
       </p:sp>
@@ -541,6 +546,7 @@
               <a:rPr lang="zh-CN" altLang="en-US"/>
               <a:t>单击此处编辑母版文本样式</a:t>
             </a:r>
+            <a:endParaRPr lang="zh-CN" altLang="en-US"/>
           </a:p>
           <a:p>
             <a:pPr lvl="1"/>
@@ -548,6 +554,7 @@
               <a:rPr lang="zh-CN" altLang="en-US"/>
               <a:t>第二级</a:t>
             </a:r>
+            <a:endParaRPr lang="zh-CN" altLang="en-US"/>
           </a:p>
           <a:p>
             <a:pPr lvl="2"/>
@@ -555,6 +562,7 @@
               <a:rPr lang="zh-CN" altLang="en-US"/>
               <a:t>第三级</a:t>
             </a:r>
+            <a:endParaRPr lang="zh-CN" altLang="en-US"/>
           </a:p>
           <a:p>
             <a:pPr lvl="3"/>
@@ -562,6 +570,7 @@
               <a:rPr lang="zh-CN" altLang="en-US"/>
               <a:t>第四级</a:t>
             </a:r>
+            <a:endParaRPr lang="zh-CN" altLang="en-US"/>
           </a:p>
           <a:p>
             <a:pPr lvl="4"/>
@@ -569,6 +578,7 @@
               <a:rPr lang="zh-CN" altLang="en-US"/>
               <a:t>第五级</a:t>
             </a:r>
+            <a:endParaRPr lang="zh-CN" altLang="en-US"/>
           </a:p>
         </p:txBody>
       </p:sp>
@@ -589,7 +599,6 @@
           <a:p>
             <a:fld id="{D997B5FA-0921-464F-AAE1-844C04324D75}" type="datetimeFigureOut">
               <a:rPr lang="zh-CN" altLang="en-US" smtClean="0"/>
-              <a:t>2026/7/8</a:t>
             </a:fld>
             <a:endParaRPr lang="zh-CN" altLang="en-US"/>
           </a:p>
@@ -631,7 +640,6 @@
           <a:p>
             <a:fld id="{565CE74E-AB26-4998-AD42-012C4C1AD076}" type="slidenum">
               <a:rPr lang="zh-CN" altLang="en-US" smtClean="0"/>
-              <a:t>‹#›</a:t>
             </a:fld>
             <a:endParaRPr lang="zh-CN" altLang="en-US"/>
           </a:p>
@@ -681,6 +689,7 @@
               <a:rPr lang="zh-CN" altLang="en-US"/>
               <a:t>单击此处编辑母版标题样式</a:t>
             </a:r>
+            <a:endParaRPr lang="zh-CN" altLang="en-US"/>
           </a:p>
         </p:txBody>
       </p:sp>
@@ -704,6 +713,7 @@
               <a:rPr lang="zh-CN" altLang="en-US"/>
               <a:t>单击此处编辑母版文本样式</a:t>
             </a:r>
+            <a:endParaRPr lang="zh-CN" altLang="en-US"/>
           </a:p>
           <a:p>
             <a:pPr lvl="1"/>
@@ -711,6 +721,7 @@
               <a:rPr lang="zh-CN" altLang="en-US"/>
               <a:t>第二级</a:t>
             </a:r>
+            <a:endParaRPr lang="zh-CN" altLang="en-US"/>
           </a:p>
           <a:p>
             <a:pPr lvl="2"/>
@@ -718,6 +729,7 @@
               <a:rPr lang="zh-CN" altLang="en-US"/>
               <a:t>第三级</a:t>
             </a:r>
+            <a:endParaRPr lang="zh-CN" altLang="en-US"/>
           </a:p>
           <a:p>
             <a:pPr lvl="3"/>
@@ -725,6 +737,7 @@
               <a:rPr lang="zh-CN" altLang="en-US"/>
               <a:t>第四级</a:t>
             </a:r>
+            <a:endParaRPr lang="zh-CN" altLang="en-US"/>
           </a:p>
           <a:p>
             <a:pPr lvl="4"/>
@@ -732,6 +745,7 @@
               <a:rPr lang="zh-CN" altLang="en-US"/>
               <a:t>第五级</a:t>
             </a:r>
+            <a:endParaRPr lang="zh-CN" altLang="en-US"/>
           </a:p>
         </p:txBody>
       </p:sp>
@@ -752,7 +766,6 @@
           <a:p>
             <a:fld id="{D997B5FA-0921-464F-AAE1-844C04324D75}" type="datetimeFigureOut">
               <a:rPr lang="zh-CN" altLang="en-US" smtClean="0"/>
-              <a:t>2026/7/8</a:t>
             </a:fld>
             <a:endParaRPr lang="zh-CN" altLang="en-US"/>
           </a:p>
@@ -794,7 +807,6 @@
           <a:p>
             <a:fld id="{565CE74E-AB26-4998-AD42-012C4C1AD076}" type="slidenum">
               <a:rPr lang="zh-CN" altLang="en-US" smtClean="0"/>
-              <a:t>‹#›</a:t>
             </a:fld>
             <a:endParaRPr lang="zh-CN" altLang="en-US"/>
           </a:p>
@@ -853,6 +865,7 @@
               <a:rPr lang="zh-CN" altLang="en-US"/>
               <a:t>单击此处编辑母版标题样式</a:t>
             </a:r>
+            <a:endParaRPr lang="zh-CN" altLang="en-US"/>
           </a:p>
         </p:txBody>
       </p:sp>
@@ -972,6 +985,7 @@
               <a:rPr lang="zh-CN" altLang="en-US"/>
               <a:t>单击此处编辑母版文本样式</a:t>
             </a:r>
+            <a:endParaRPr lang="zh-CN" altLang="en-US"/>
           </a:p>
         </p:txBody>
       </p:sp>
@@ -992,7 +1006,6 @@
           <a:p>
             <a:fld id="{D997B5FA-0921-464F-AAE1-844C04324D75}" type="datetimeFigureOut">
               <a:rPr lang="zh-CN" altLang="en-US" smtClean="0"/>
-              <a:t>2026/7/8</a:t>
             </a:fld>
             <a:endParaRPr lang="zh-CN" altLang="en-US"/>
           </a:p>
@@ -1034,7 +1047,6 @@
           <a:p>
             <a:fld id="{565CE74E-AB26-4998-AD42-012C4C1AD076}" type="slidenum">
               <a:rPr lang="zh-CN" altLang="en-US" smtClean="0"/>
-              <a:t>‹#›</a:t>
             </a:fld>
             <a:endParaRPr lang="zh-CN" altLang="en-US"/>
           </a:p>
@@ -1084,6 +1096,7 @@
               <a:rPr lang="zh-CN" altLang="en-US"/>
               <a:t>单击此处编辑母版标题样式</a:t>
             </a:r>
+            <a:endParaRPr lang="zh-CN" altLang="en-US"/>
           </a:p>
         </p:txBody>
       </p:sp>
@@ -1112,6 +1125,7 @@
               <a:rPr lang="zh-CN" altLang="en-US"/>
               <a:t>单击此处编辑母版文本样式</a:t>
             </a:r>
+            <a:endParaRPr lang="zh-CN" altLang="en-US"/>
           </a:p>
           <a:p>
             <a:pPr lvl="1"/>
@@ -1119,6 +1133,7 @@
               <a:rPr lang="zh-CN" altLang="en-US"/>
               <a:t>第二级</a:t>
             </a:r>
+            <a:endParaRPr lang="zh-CN" altLang="en-US"/>
           </a:p>
           <a:p>
             <a:pPr lvl="2"/>
@@ -1126,6 +1141,7 @@
               <a:rPr lang="zh-CN" altLang="en-US"/>
               <a:t>第三级</a:t>
             </a:r>
+            <a:endParaRPr lang="zh-CN" altLang="en-US"/>
           </a:p>
           <a:p>
             <a:pPr lvl="3"/>
@@ -1133,6 +1149,7 @@
               <a:rPr lang="zh-CN" altLang="en-US"/>
               <a:t>第四级</a:t>
             </a:r>
+            <a:endParaRPr lang="zh-CN" altLang="en-US"/>
           </a:p>
           <a:p>
             <a:pPr lvl="4"/>
@@ -1140,6 +1157,7 @@
               <a:rPr lang="zh-CN" altLang="en-US"/>
               <a:t>第五级</a:t>
             </a:r>
+            <a:endParaRPr lang="zh-CN" altLang="en-US"/>
           </a:p>
         </p:txBody>
       </p:sp>
@@ -1168,6 +1186,7 @@
               <a:rPr lang="zh-CN" altLang="en-US"/>
               <a:t>单击此处编辑母版文本样式</a:t>
             </a:r>
+            <a:endParaRPr lang="zh-CN" altLang="en-US"/>
           </a:p>
           <a:p>
             <a:pPr lvl="1"/>
@@ -1175,6 +1194,7 @@
               <a:rPr lang="zh-CN" altLang="en-US"/>
               <a:t>第二级</a:t>
             </a:r>
+            <a:endParaRPr lang="zh-CN" altLang="en-US"/>
           </a:p>
           <a:p>
             <a:pPr lvl="2"/>
@@ -1182,6 +1202,7 @@
               <a:rPr lang="zh-CN" altLang="en-US"/>
               <a:t>第三级</a:t>
             </a:r>
+            <a:endParaRPr lang="zh-CN" altLang="en-US"/>
           </a:p>
           <a:p>
             <a:pPr lvl="3"/>
@@ -1189,6 +1210,7 @@
               <a:rPr lang="zh-CN" altLang="en-US"/>
               <a:t>第四级</a:t>
             </a:r>
+            <a:endParaRPr lang="zh-CN" altLang="en-US"/>
           </a:p>
           <a:p>
             <a:pPr lvl="4"/>
@@ -1196,6 +1218,7 @@
               <a:rPr lang="zh-CN" altLang="en-US"/>
               <a:t>第五级</a:t>
             </a:r>
+            <a:endParaRPr lang="zh-CN" altLang="en-US"/>
           </a:p>
         </p:txBody>
       </p:sp>
@@ -1216,7 +1239,6 @@
           <a:p>
             <a:fld id="{D997B5FA-0921-464F-AAE1-844C04324D75}" type="datetimeFigureOut">
               <a:rPr lang="zh-CN" altLang="en-US" smtClean="0"/>
-              <a:t>2026/7/8</a:t>
             </a:fld>
             <a:endParaRPr lang="zh-CN" altLang="en-US"/>
           </a:p>
@@ -1258,7 +1280,6 @@
           <a:p>
             <a:fld id="{565CE74E-AB26-4998-AD42-012C4C1AD076}" type="slidenum">
               <a:rPr lang="zh-CN" altLang="en-US" smtClean="0"/>
-              <a:t>‹#›</a:t>
             </a:fld>
             <a:endParaRPr lang="zh-CN" altLang="en-US"/>
           </a:p>
@@ -1313,6 +1334,7 @@
               <a:rPr lang="zh-CN" altLang="en-US"/>
               <a:t>单击此处编辑母版标题样式</a:t>
             </a:r>
+            <a:endParaRPr lang="zh-CN" altLang="en-US"/>
           </a:p>
         </p:txBody>
       </p:sp>
@@ -1378,6 +1400,7 @@
               <a:rPr lang="zh-CN" altLang="en-US"/>
               <a:t>单击此处编辑母版文本样式</a:t>
             </a:r>
+            <a:endParaRPr lang="zh-CN" altLang="en-US"/>
           </a:p>
         </p:txBody>
       </p:sp>
@@ -1406,6 +1429,7 @@
               <a:rPr lang="zh-CN" altLang="en-US"/>
               <a:t>单击此处编辑母版文本样式</a:t>
             </a:r>
+            <a:endParaRPr lang="zh-CN" altLang="en-US"/>
           </a:p>
           <a:p>
             <a:pPr lvl="1"/>
@@ -1413,6 +1437,7 @@
               <a:rPr lang="zh-CN" altLang="en-US"/>
               <a:t>第二级</a:t>
             </a:r>
+            <a:endParaRPr lang="zh-CN" altLang="en-US"/>
           </a:p>
           <a:p>
             <a:pPr lvl="2"/>
@@ -1420,6 +1445,7 @@
               <a:rPr lang="zh-CN" altLang="en-US"/>
               <a:t>第三级</a:t>
             </a:r>
+            <a:endParaRPr lang="zh-CN" altLang="en-US"/>
           </a:p>
           <a:p>
             <a:pPr lvl="3"/>
@@ -1427,6 +1453,7 @@
               <a:rPr lang="zh-CN" altLang="en-US"/>
               <a:t>第四级</a:t>
             </a:r>
+            <a:endParaRPr lang="zh-CN" altLang="en-US"/>
           </a:p>
           <a:p>
             <a:pPr lvl="4"/>
@@ -1434,6 +1461,7 @@
               <a:rPr lang="zh-CN" altLang="en-US"/>
               <a:t>第五级</a:t>
             </a:r>
+            <a:endParaRPr lang="zh-CN" altLang="en-US"/>
           </a:p>
         </p:txBody>
       </p:sp>
@@ -1499,6 +1527,7 @@
               <a:rPr lang="zh-CN" altLang="en-US"/>
               <a:t>单击此处编辑母版文本样式</a:t>
             </a:r>
+            <a:endParaRPr lang="zh-CN" altLang="en-US"/>
           </a:p>
         </p:txBody>
       </p:sp>
@@ -1527,6 +1556,7 @@
               <a:rPr lang="zh-CN" altLang="en-US"/>
               <a:t>单击此处编辑母版文本样式</a:t>
             </a:r>
+            <a:endParaRPr lang="zh-CN" altLang="en-US"/>
           </a:p>
           <a:p>
             <a:pPr lvl="1"/>
@@ -1534,6 +1564,7 @@
               <a:rPr lang="zh-CN" altLang="en-US"/>
               <a:t>第二级</a:t>
             </a:r>
+            <a:endParaRPr lang="zh-CN" altLang="en-US"/>
           </a:p>
           <a:p>
             <a:pPr lvl="2"/>
@@ -1541,6 +1572,7 @@
               <a:rPr lang="zh-CN" altLang="en-US"/>
               <a:t>第三级</a:t>
             </a:r>
+            <a:endParaRPr lang="zh-CN" altLang="en-US"/>
           </a:p>
           <a:p>
             <a:pPr lvl="3"/>
@@ -1548,6 +1580,7 @@
               <a:rPr lang="zh-CN" altLang="en-US"/>
               <a:t>第四级</a:t>
             </a:r>
+            <a:endParaRPr lang="zh-CN" altLang="en-US"/>
           </a:p>
           <a:p>
             <a:pPr lvl="4"/>
@@ -1555,6 +1588,7 @@
               <a:rPr lang="zh-CN" altLang="en-US"/>
               <a:t>第五级</a:t>
             </a:r>
+            <a:endParaRPr lang="zh-CN" altLang="en-US"/>
           </a:p>
         </p:txBody>
       </p:sp>
@@ -1575,7 +1609,6 @@
           <a:p>
             <a:fld id="{D997B5FA-0921-464F-AAE1-844C04324D75}" type="datetimeFigureOut">
               <a:rPr lang="zh-CN" altLang="en-US" smtClean="0"/>
-              <a:t>2026/7/8</a:t>
             </a:fld>
             <a:endParaRPr lang="zh-CN" altLang="en-US"/>
           </a:p>
@@ -1617,7 +1650,6 @@
           <a:p>
             <a:fld id="{565CE74E-AB26-4998-AD42-012C4C1AD076}" type="slidenum">
               <a:rPr lang="zh-CN" altLang="en-US" smtClean="0"/>
-              <a:t>‹#›</a:t>
             </a:fld>
             <a:endParaRPr lang="zh-CN" altLang="en-US"/>
           </a:p>
@@ -1667,6 +1699,7 @@
               <a:rPr lang="zh-CN" altLang="en-US"/>
               <a:t>单击此处编辑母版标题样式</a:t>
             </a:r>
+            <a:endParaRPr lang="zh-CN" altLang="en-US"/>
           </a:p>
         </p:txBody>
       </p:sp>
@@ -1687,7 +1720,6 @@
           <a:p>
             <a:fld id="{D997B5FA-0921-464F-AAE1-844C04324D75}" type="datetimeFigureOut">
               <a:rPr lang="zh-CN" altLang="en-US" smtClean="0"/>
-              <a:t>2026/7/8</a:t>
             </a:fld>
             <a:endParaRPr lang="zh-CN" altLang="en-US"/>
           </a:p>
@@ -1729,7 +1761,6 @@
           <a:p>
             <a:fld id="{565CE74E-AB26-4998-AD42-012C4C1AD076}" type="slidenum">
               <a:rPr lang="zh-CN" altLang="en-US" smtClean="0"/>
-              <a:t>‹#›</a:t>
             </a:fld>
             <a:endParaRPr lang="zh-CN" altLang="en-US"/>
           </a:p>
@@ -1777,7 +1808,6 @@
           <a:p>
             <a:fld id="{D997B5FA-0921-464F-AAE1-844C04324D75}" type="datetimeFigureOut">
               <a:rPr lang="zh-CN" altLang="en-US" smtClean="0"/>
-              <a:t>2026/7/8</a:t>
             </a:fld>
             <a:endParaRPr lang="zh-CN" altLang="en-US"/>
           </a:p>
@@ -1819,7 +1849,6 @@
           <a:p>
             <a:fld id="{565CE74E-AB26-4998-AD42-012C4C1AD076}" type="slidenum">
               <a:rPr lang="zh-CN" altLang="en-US" smtClean="0"/>
-              <a:t>‹#›</a:t>
             </a:fld>
             <a:endParaRPr lang="zh-CN" altLang="en-US"/>
           </a:p>
@@ -1878,6 +1907,7 @@
               <a:rPr lang="zh-CN" altLang="en-US"/>
               <a:t>单击此处编辑母版标题样式</a:t>
             </a:r>
+            <a:endParaRPr lang="zh-CN" altLang="en-US"/>
           </a:p>
         </p:txBody>
       </p:sp>
@@ -1934,6 +1964,7 @@
               <a:rPr lang="zh-CN" altLang="en-US"/>
               <a:t>单击此处编辑母版文本样式</a:t>
             </a:r>
+            <a:endParaRPr lang="zh-CN" altLang="en-US"/>
           </a:p>
           <a:p>
             <a:pPr lvl="1"/>
@@ -1941,6 +1972,7 @@
               <a:rPr lang="zh-CN" altLang="en-US"/>
               <a:t>第二级</a:t>
             </a:r>
+            <a:endParaRPr lang="zh-CN" altLang="en-US"/>
           </a:p>
           <a:p>
             <a:pPr lvl="2"/>
@@ -1948,6 +1980,7 @@
               <a:rPr lang="zh-CN" altLang="en-US"/>
               <a:t>第三级</a:t>
             </a:r>
+            <a:endParaRPr lang="zh-CN" altLang="en-US"/>
           </a:p>
           <a:p>
             <a:pPr lvl="3"/>
@@ -1955,6 +1988,7 @@
               <a:rPr lang="zh-CN" altLang="en-US"/>
               <a:t>第四级</a:t>
             </a:r>
+            <a:endParaRPr lang="zh-CN" altLang="en-US"/>
           </a:p>
           <a:p>
             <a:pPr lvl="4"/>
@@ -1962,6 +1996,7 @@
               <a:rPr lang="zh-CN" altLang="en-US"/>
               <a:t>第五级</a:t>
             </a:r>
+            <a:endParaRPr lang="zh-CN" altLang="en-US"/>
           </a:p>
         </p:txBody>
       </p:sp>
@@ -2027,6 +2062,7 @@
               <a:rPr lang="zh-CN" altLang="en-US"/>
               <a:t>单击此处编辑母版文本样式</a:t>
             </a:r>
+            <a:endParaRPr lang="zh-CN" altLang="en-US"/>
           </a:p>
         </p:txBody>
       </p:sp>
@@ -2047,7 +2083,6 @@
           <a:p>
             <a:fld id="{D997B5FA-0921-464F-AAE1-844C04324D75}" type="datetimeFigureOut">
               <a:rPr lang="zh-CN" altLang="en-US" smtClean="0"/>
-              <a:t>2026/7/8</a:t>
             </a:fld>
             <a:endParaRPr lang="zh-CN" altLang="en-US"/>
           </a:p>
@@ -2089,7 +2124,6 @@
           <a:p>
             <a:fld id="{565CE74E-AB26-4998-AD42-012C4C1AD076}" type="slidenum">
               <a:rPr lang="zh-CN" altLang="en-US" smtClean="0"/>
-              <a:t>‹#›</a:t>
             </a:fld>
             <a:endParaRPr lang="zh-CN" altLang="en-US"/>
           </a:p>
@@ -2148,6 +2182,7 @@
               <a:rPr lang="zh-CN" altLang="en-US"/>
               <a:t>单击此处编辑母版标题样式</a:t>
             </a:r>
+            <a:endParaRPr lang="zh-CN" altLang="en-US"/>
           </a:p>
         </p:txBody>
       </p:sp>
@@ -2274,6 +2309,7 @@
               <a:rPr lang="zh-CN" altLang="en-US"/>
               <a:t>单击此处编辑母版文本样式</a:t>
             </a:r>
+            <a:endParaRPr lang="zh-CN" altLang="en-US"/>
           </a:p>
         </p:txBody>
       </p:sp>
@@ -2294,7 +2330,6 @@
           <a:p>
             <a:fld id="{D997B5FA-0921-464F-AAE1-844C04324D75}" type="datetimeFigureOut">
               <a:rPr lang="zh-CN" altLang="en-US" smtClean="0"/>
-              <a:t>2026/7/8</a:t>
             </a:fld>
             <a:endParaRPr lang="zh-CN" altLang="en-US"/>
           </a:p>
@@ -2336,7 +2371,6 @@
           <a:p>
             <a:fld id="{565CE74E-AB26-4998-AD42-012C4C1AD076}" type="slidenum">
               <a:rPr lang="zh-CN" altLang="en-US" smtClean="0"/>
-              <a:t>‹#›</a:t>
             </a:fld>
             <a:endParaRPr lang="zh-CN" altLang="en-US"/>
           </a:p>
@@ -2401,6 +2435,7 @@
               <a:rPr lang="zh-CN" altLang="en-US"/>
               <a:t>单击此处编辑母版标题样式</a:t>
             </a:r>
+            <a:endParaRPr lang="zh-CN" altLang="en-US"/>
           </a:p>
         </p:txBody>
       </p:sp>
@@ -2434,6 +2469,7 @@
               <a:rPr lang="zh-CN" altLang="en-US"/>
               <a:t>单击此处编辑母版文本样式</a:t>
             </a:r>
+            <a:endParaRPr lang="zh-CN" altLang="en-US"/>
           </a:p>
           <a:p>
             <a:pPr lvl="1"/>
@@ -2441,6 +2477,7 @@
               <a:rPr lang="zh-CN" altLang="en-US"/>
               <a:t>第二级</a:t>
             </a:r>
+            <a:endParaRPr lang="zh-CN" altLang="en-US"/>
           </a:p>
           <a:p>
             <a:pPr lvl="2"/>
@@ -2448,6 +2485,7 @@
               <a:rPr lang="zh-CN" altLang="en-US"/>
               <a:t>第三级</a:t>
             </a:r>
+            <a:endParaRPr lang="zh-CN" altLang="en-US"/>
           </a:p>
           <a:p>
             <a:pPr lvl="3"/>
@@ -2455,6 +2493,7 @@
               <a:rPr lang="zh-CN" altLang="en-US"/>
               <a:t>第四级</a:t>
             </a:r>
+            <a:endParaRPr lang="zh-CN" altLang="en-US"/>
           </a:p>
           <a:p>
             <a:pPr lvl="4"/>
@@ -2462,6 +2501,7 @@
               <a:rPr lang="zh-CN" altLang="en-US"/>
               <a:t>第五级</a:t>
             </a:r>
+            <a:endParaRPr lang="zh-CN" altLang="en-US"/>
           </a:p>
         </p:txBody>
       </p:sp>
@@ -2500,7 +2540,6 @@
           <a:p>
             <a:fld id="{D997B5FA-0921-464F-AAE1-844C04324D75}" type="datetimeFigureOut">
               <a:rPr lang="zh-CN" altLang="en-US" smtClean="0"/>
-              <a:t>2026/7/8</a:t>
             </a:fld>
             <a:endParaRPr lang="zh-CN" altLang="en-US"/>
           </a:p>
@@ -2578,7 +2617,6 @@
           <a:p>
             <a:fld id="{565CE74E-AB26-4998-AD42-012C4C1AD076}" type="slidenum">
               <a:rPr lang="zh-CN" altLang="en-US" smtClean="0"/>
-              <a:t>‹#›</a:t>
             </a:fld>
             <a:endParaRPr lang="zh-CN" altLang="en-US"/>
           </a:p>
@@ -2979,25 +3017,14 @@
               <a:buChar char="•"/>
             </a:pPr>
             <a:r>
-              <a:rPr lang="en-US" sz="1800" b="1" i="0" dirty="0">
-                <a:solidFill>
-                  <a:srgbClr val="1F1F1F"/>
-                </a:solidFill>
-                <a:effectLst/>
-                <a:latin typeface="Google Sans Flex"/>
-              </a:rPr>
+              <a:rPr lang="en-US" sz="1800" i="0" dirty="0"/>
               <a:t>Definition of the Camera's Canonical Coordinate System</a:t>
             </a:r>
             <a:r>
-              <a:rPr lang="en-US" sz="1800" b="0" i="0" dirty="0">
-                <a:solidFill>
-                  <a:srgbClr val="1F1F1F"/>
-                </a:solidFill>
-                <a:effectLst/>
-                <a:latin typeface="Google Sans Flex"/>
-              </a:rPr>
+              <a:rPr lang="en-US" sz="1800" b="0" i="0" dirty="0"/>
               <a:t>: For the view frustum and forward-facing direction, the camera's canonical coordinate system is defined with the Z-axis (blue) pointing forward, X-axis (red) pointing right, and Y-axis (green) pointing down.</a:t>
             </a:r>
+            <a:endParaRPr lang="en-US" sz="1800" b="0" i="0" dirty="0"/>
           </a:p>
           <a:p>
             <a:r>
@@ -3017,15 +3044,15 @@
           <p:nvPr/>
         </p:nvPicPr>
         <p:blipFill>
-          <a:blip r:embed="rId2"/>
+          <a:blip r:embed="rId1"/>
           <a:stretch>
             <a:fillRect/>
           </a:stretch>
         </p:blipFill>
         <p:spPr>
           <a:xfrm>
-            <a:off x="1580424" y="2374358"/>
-            <a:ext cx="8595541" cy="4212405"/>
+            <a:off x="1809115" y="2486025"/>
+            <a:ext cx="8366760" cy="4100830"/>
           </a:xfrm>
           <a:prstGeom prst="rect">
             <a:avLst/>
@@ -3107,6 +3134,7 @@
               <a:rPr lang="zh-CN" altLang="en-US" sz="2800" b="1" dirty="0"/>
               <a:t>？</a:t>
             </a:r>
+            <a:endParaRPr lang="zh-CN" altLang="en-US" sz="2800" b="1" dirty="0"/>
           </a:p>
         </p:txBody>
       </p:sp>
@@ -3161,6 +3189,7 @@
               <a:rPr lang="en-US" sz="1800" dirty="0"/>
               <a:t>Then drag the progress bar to check whether the movement trend of the gripper coordinate below matches the trend in the video.</a:t>
             </a:r>
+            <a:endParaRPr lang="en-US" sz="1800" dirty="0"/>
           </a:p>
           <a:p>
             <a:pPr algn="just"/>
@@ -3195,16 +3224,16 @@
           </p:cNvPr>
           <p:cNvPicPr/>
           <p:nvPr>
-            <a:videoFile r:link="rId2"/>
+            <a:videoFile r:link="rId1"/>
             <p:extLst>
               <p:ext uri="{DAA4B4D4-6D71-4841-9C94-3DE7FCFB9230}">
-                <p14:media xmlns:p14="http://schemas.microsoft.com/office/powerpoint/2010/main" r:embed="rId1"/>
+                <p14:media xmlns:p14="http://schemas.microsoft.com/office/powerpoint/2010/main" r:embed="rId2"/>
               </p:ext>
             </p:extLst>
           </p:nvPr>
         </p:nvPicPr>
         <p:blipFill>
-          <a:blip r:embed="rId4"/>
+          <a:blip r:embed="rId3"/>
           <a:stretch>
             <a:fillRect/>
           </a:stretch>
@@ -3550,8 +3579,6 @@
       </a:bgFillStyleLst>
     </a:fmtScheme>
   </a:themeElements>
-  <a:objectDefaults/>
-  <a:extraClrSchemeLst/>
   <a:extLst>
     <a:ext uri="{05A4C25C-085E-4340-85A3-A5531E510DB2}">
       <thm15:themeFamily xmlns:thm15="http://schemas.microsoft.com/office/thememl/2012/main" name="Office Theme" id="{62F939B6-93AF-4DB8-9C6B-D6C7DFDC589F}" vid="{4A3C46E8-61CC-4603-A589-7422A47A8E4A}"/>

</xml_diff>